<commit_message>
Versión final del informe y la presentación
</commit_message>
<xml_diff>
--- a/Presentacion.pptx
+++ b/Presentacion.pptx
@@ -1386,7 +1386,9 @@
               <a:t>PRESENTA: Integrante B · 3:10–3:45 (35 s)</a:t>
             </a:r>
           </a:p>
-          <a:p/>
+          <a:p>
+            <a:endParaRPr/>
+          </a:p>
           <a:p>
             <a:r>
               <a:t>QUÉ DECIR:</a:t>
@@ -1397,7 +1399,9 @@
               <a:t>Medimos el sistema durante siete días con las consolas de Firebase y Vercel. En Vercel tuvimos 3.857 invocaciones diarias, solo un 11 % menos de lo estimado. En Firestore medimos menos: 1.217 escrituras y 2.224 lecturas al día, porque la Raspberry no estuvo encendida las 24 horas todos los días y el histórico se consultó menos de lo supuesto. Aun así, el día de mayor actividad llegó a 2.900 escrituras, prácticamente lo estimado para un día completo, lo que valida el cálculo.</a:t>
             </a:r>
           </a:p>
-          <a:p/>
+          <a:p>
+            <a:endParaRPr/>
+          </a:p>
           <a:p>
             <a:r>
               <a:t>SI PREGUNTAN:</a:t>
@@ -1696,7 +1700,7 @@
           </a:prstGeom>
           <a:extLst>
             <a:ext uri="{C572A759-6A51-4108-AA02-DFA0A04FC94B}">
-              <ma14:wrappingTextBoxFlag xmlns:ma14="http://schemas.microsoft.com/office/mac/drawingml/2011/main" xmlns="" val="0"/>
+              <ma14:wrappingTextBoxFlag xmlns="" xmlns:ma14="http://schemas.microsoft.com/office/mac/drawingml/2011/main" val="0"/>
             </a:ext>
           </a:extLst>
         </p:spPr>
@@ -1845,7 +1849,7 @@
           </a:prstGeom>
           <a:extLst>
             <a:ext uri="{C572A759-6A51-4108-AA02-DFA0A04FC94B}">
-              <ma14:wrappingTextBoxFlag xmlns:ma14="http://schemas.microsoft.com/office/mac/drawingml/2011/main" xmlns="" val="0"/>
+              <ma14:wrappingTextBoxFlag xmlns="" xmlns:ma14="http://schemas.microsoft.com/office/mac/drawingml/2011/main" val="0"/>
             </a:ext>
           </a:extLst>
         </p:spPr>
@@ -2786,7 +2790,7 @@
           </a:prstGeom>
           <a:extLst>
             <a:ext uri="{C572A759-6A51-4108-AA02-DFA0A04FC94B}">
-              <ma14:wrappingTextBoxFlag xmlns:ma14="http://schemas.microsoft.com/office/mac/drawingml/2011/main" xmlns="" val="0"/>
+              <ma14:wrappingTextBoxFlag xmlns="" xmlns:ma14="http://schemas.microsoft.com/office/mac/drawingml/2011/main" val="0"/>
             </a:ext>
           </a:extLst>
         </p:spPr>
@@ -3455,7 +3459,7 @@
           </a:prstGeom>
           <a:extLst>
             <a:ext uri="{C572A759-6A51-4108-AA02-DFA0A04FC94B}">
-              <ma14:wrappingTextBoxFlag xmlns:ma14="http://schemas.microsoft.com/office/mac/drawingml/2011/main" xmlns="" val="0"/>
+              <ma14:wrappingTextBoxFlag xmlns="" xmlns:ma14="http://schemas.microsoft.com/office/mac/drawingml/2011/main" val="0"/>
             </a:ext>
           </a:extLst>
         </p:spPr>
@@ -5349,7 +5353,7 @@
           </a:prstGeom>
           <a:extLst>
             <a:ext uri="{C572A759-6A51-4108-AA02-DFA0A04FC94B}">
-              <ma14:wrappingTextBoxFlag xmlns:ma14="http://schemas.microsoft.com/office/mac/drawingml/2011/main" xmlns="" val="0"/>
+              <ma14:wrappingTextBoxFlag xmlns="" xmlns:ma14="http://schemas.microsoft.com/office/mac/drawingml/2011/main" val="0"/>
             </a:ext>
           </a:extLst>
         </p:spPr>
@@ -6668,7 +6672,7 @@
           </a:prstGeom>
           <a:extLst>
             <a:ext uri="{C572A759-6A51-4108-AA02-DFA0A04FC94B}">
-              <ma14:wrappingTextBoxFlag xmlns:ma14="http://schemas.microsoft.com/office/mac/drawingml/2011/main" xmlns="" val="0"/>
+              <ma14:wrappingTextBoxFlag xmlns="" xmlns:ma14="http://schemas.microsoft.com/office/mac/drawingml/2011/main" val="0"/>
             </a:ext>
           </a:extLst>
         </p:spPr>
@@ -7142,7 +7146,7 @@
           </a:prstGeom>
           <a:extLst>
             <a:ext uri="{C572A759-6A51-4108-AA02-DFA0A04FC94B}">
-              <ma14:wrappingTextBoxFlag xmlns:ma14="http://schemas.microsoft.com/office/mac/drawingml/2011/main" xmlns="" val="0"/>
+              <ma14:wrappingTextBoxFlag xmlns="" xmlns:ma14="http://schemas.microsoft.com/office/mac/drawingml/2011/main" val="0"/>
             </a:ext>
           </a:extLst>
         </p:spPr>
@@ -7620,7 +7624,7 @@
           </a:prstGeom>
           <a:extLst>
             <a:ext uri="{C572A759-6A51-4108-AA02-DFA0A04FC94B}">
-              <ma14:wrappingTextBoxFlag xmlns:ma14="http://schemas.microsoft.com/office/mac/drawingml/2011/main" xmlns="" val="0"/>
+              <ma14:wrappingTextBoxFlag xmlns="" xmlns:ma14="http://schemas.microsoft.com/office/mac/drawingml/2011/main" val="0"/>
             </a:ext>
           </a:extLst>
         </p:spPr>
@@ -8244,7 +8248,7 @@
           </a:prstGeom>
           <a:extLst>
             <a:ext uri="{C572A759-6A51-4108-AA02-DFA0A04FC94B}">
-              <ma14:wrappingTextBoxFlag xmlns:ma14="http://schemas.microsoft.com/office/mac/drawingml/2011/main" xmlns="" val="0"/>
+              <ma14:wrappingTextBoxFlag xmlns="" xmlns:ma14="http://schemas.microsoft.com/office/mac/drawingml/2011/main" val="0"/>
             </a:ext>
           </a:extLst>
         </p:spPr>
@@ -9824,7 +9828,7 @@
           </a:prstGeom>
           <a:extLst>
             <a:ext uri="{C572A759-6A51-4108-AA02-DFA0A04FC94B}">
-              <ma14:wrappingTextBoxFlag xmlns:ma14="http://schemas.microsoft.com/office/mac/drawingml/2011/main" xmlns="" val="0"/>
+              <ma14:wrappingTextBoxFlag xmlns="" xmlns:ma14="http://schemas.microsoft.com/office/mac/drawingml/2011/main" val="0"/>
             </a:ext>
           </a:extLst>
         </p:spPr>
@@ -10792,42 +10796,6 @@
       </p:graphicFrame>
       <p:sp>
         <p:nvSpPr>
-          <p:cNvPr id="7" name="Text 3"/>
-          <p:cNvSpPr txBox="1"/>
-          <p:nvPr/>
-        </p:nvSpPr>
-        <p:spPr>
-          <a:xfrm>
-            <a:off x="6309360" y="4709160"/>
-            <a:ext cx="5333695" cy="731520"/>
-          </a:xfrm>
-          <a:prstGeom prst="rect">
-            <a:avLst/>
-          </a:prstGeom>
-          <a:noFill/>
-          <a:ln/>
-        </p:spPr>
-        <p:txBody>
-          <a:bodyPr wrap="square" lIns="0" tIns="0" rIns="0" bIns="0" rtlCol="0" anchor="ctr"/>
-          <a:lstStyle/>
-          <a:p>
-            <a:pPr marL="0" indent="0">
-              <a:buNone/>
-            </a:pPr>
-            <a:r>
-              <a:rPr lang="en-US" sz="1500" b="1" dirty="0">
-                <a:solidFill>
-                  <a:schemeClr val="accent1"/>
-                </a:solidFill>
-              </a:rPr>
-              <a:t>Recomendación: PaaS. La IaaS ahorra ≈ USD 10 al mes, pero el grupo tendría que operarla entera.</a:t>
-            </a:r>
-            <a:endParaRPr lang="en-US" sz="1500" dirty="0"/>
-          </a:p>
-        </p:txBody>
-      </p:sp>
-      <p:sp>
-        <p:nvSpPr>
           <p:cNvPr id="25" name="Slide Number Placeholder 0"/>
           <p:cNvSpPr>
             <a:spLocks noGrp="1"/>
@@ -10846,7 +10814,7 @@
           </a:prstGeom>
           <a:extLst>
             <a:ext uri="{C572A759-6A51-4108-AA02-DFA0A04FC94B}">
-              <ma14:wrappingTextBoxFlag xmlns:ma14="http://schemas.microsoft.com/office/mac/drawingml/2011/main" xmlns="" val="0"/>
+              <ma14:wrappingTextBoxFlag xmlns="" xmlns:ma14="http://schemas.microsoft.com/office/mac/drawingml/2011/main" val="0"/>
             </a:ext>
           </a:extLst>
         </p:spPr>

</xml_diff>